<commit_message>
Update: real FK logo, Team MetaBot branding, HD video (CRF14/30fps), corrected data
</commit_message>
<xml_diff>
--- a/assets/ParkIQ_Presentation.pptx
+++ b/assets/ParkIQ_Presentation.pptx
@@ -3286,7 +3286,7 @@
                   <a:srgbClr val="AAAAAA"/>
                 </a:solidFill>
               </a:rPr>
-              <a:t>Bengaluru Traffic Police | Gridlock Hackathon 2.0 Round 2</a:t>
+              <a:t>Bengaluru Traffic Police | Flipkart Gridlock Hackathon 2.0</a:t>
             </a:r>
           </a:p>
         </p:txBody>
@@ -3534,6 +3534,75 @@
                 </a:solidFill>
               </a:rPr>
               <a:t>54 Police Stations</a:t>
+            </a:r>
+          </a:p>
+        </p:txBody>
+      </p:sp>
+      <p:pic>
+        <p:nvPicPr>
+          <p:cNvPr id="14" name="Picture 13" descr="fk-icon-CTp-Fhev.png"/>
+          <p:cNvPicPr>
+            <a:picLocks noChangeAspect="1"/>
+          </p:cNvPicPr>
+          <p:nvPr/>
+        </p:nvPicPr>
+        <p:blipFill>
+          <a:blip r:embed="rId3"/>
+          <a:stretch>
+            <a:fillRect/>
+          </a:stretch>
+        </p:blipFill>
+        <p:spPr>
+          <a:xfrm>
+            <a:off x="11640312" y="64008"/>
+            <a:ext cx="384048" cy="384048"/>
+          </a:xfrm>
+          <a:prstGeom prst="rect">
+            <a:avLst/>
+          </a:prstGeom>
+        </p:spPr>
+      </p:pic>
+      <p:sp>
+        <p:nvSpPr>
+          <p:cNvPr id="15" name="TextBox 14"/>
+          <p:cNvSpPr txBox="1"/>
+          <p:nvPr/>
+        </p:nvSpPr>
+        <p:spPr>
+          <a:xfrm>
+            <a:off x="10314432" y="100584"/>
+            <a:ext cx="1234440" cy="274320"/>
+          </a:xfrm>
+          <a:prstGeom prst="rect">
+            <a:avLst/>
+          </a:prstGeom>
+          <a:noFill/>
+          <a:solidFill>
+            <a:srgbClr val="1A1500">
+              <a:alpha val="90000"/>
+            </a:srgbClr>
+          </a:solidFill>
+          <a:ln w="9525">
+            <a:solidFill>
+              <a:srgbClr val="FFD000"/>
+            </a:solidFill>
+          </a:ln>
+          <a:prstGeom prst="roundRect"/>
+        </p:spPr>
+        <p:txBody>
+          <a:bodyPr wrap="none">
+            <a:spAutoFit/>
+          </a:bodyPr>
+          <a:lstStyle/>
+          <a:p>
+            <a:pPr algn="ctr"/>
+            <a:r>
+              <a:rPr b="1" sz="900">
+                <a:solidFill>
+                  <a:srgbClr val="FFD000"/>
+                </a:solidFill>
+              </a:rPr>
+              <a:t>Team MetaBot</a:t>
             </a:r>
           </a:p>
         </p:txBody>
@@ -4162,6 +4231,75 @@
           </a:p>
         </p:txBody>
       </p:sp>
+      <p:pic>
+        <p:nvPicPr>
+          <p:cNvPr id="18" name="Picture 17" descr="fk-icon-CTp-Fhev.png"/>
+          <p:cNvPicPr>
+            <a:picLocks noChangeAspect="1"/>
+          </p:cNvPicPr>
+          <p:nvPr/>
+        </p:nvPicPr>
+        <p:blipFill>
+          <a:blip r:embed="rId3"/>
+          <a:stretch>
+            <a:fillRect/>
+          </a:stretch>
+        </p:blipFill>
+        <p:spPr>
+          <a:xfrm>
+            <a:off x="11640312" y="64008"/>
+            <a:ext cx="384048" cy="384048"/>
+          </a:xfrm>
+          <a:prstGeom prst="rect">
+            <a:avLst/>
+          </a:prstGeom>
+        </p:spPr>
+      </p:pic>
+      <p:sp>
+        <p:nvSpPr>
+          <p:cNvPr id="19" name="TextBox 18"/>
+          <p:cNvSpPr txBox="1"/>
+          <p:nvPr/>
+        </p:nvSpPr>
+        <p:spPr>
+          <a:xfrm>
+            <a:off x="10314432" y="100584"/>
+            <a:ext cx="1234440" cy="274320"/>
+          </a:xfrm>
+          <a:prstGeom prst="rect">
+            <a:avLst/>
+          </a:prstGeom>
+          <a:noFill/>
+          <a:solidFill>
+            <a:srgbClr val="1A1500">
+              <a:alpha val="90000"/>
+            </a:srgbClr>
+          </a:solidFill>
+          <a:ln w="9525">
+            <a:solidFill>
+              <a:srgbClr val="FFD000"/>
+            </a:solidFill>
+          </a:ln>
+          <a:prstGeom prst="roundRect"/>
+        </p:spPr>
+        <p:txBody>
+          <a:bodyPr wrap="none">
+            <a:spAutoFit/>
+          </a:bodyPr>
+          <a:lstStyle/>
+          <a:p>
+            <a:pPr algn="ctr"/>
+            <a:r>
+              <a:rPr b="1" sz="900">
+                <a:solidFill>
+                  <a:srgbClr val="FFD000"/>
+                </a:solidFill>
+              </a:rPr>
+              <a:t>Team MetaBot</a:t>
+            </a:r>
+          </a:p>
+        </p:txBody>
+      </p:sp>
     </p:spTree>
   </p:cSld>
   <p:clrMapOvr>
@@ -5014,6 +5152,75 @@
           </a:p>
         </p:txBody>
       </p:sp>
+      <p:pic>
+        <p:nvPicPr>
+          <p:cNvPr id="24" name="Picture 23" descr="fk-icon-CTp-Fhev.png"/>
+          <p:cNvPicPr>
+            <a:picLocks noChangeAspect="1"/>
+          </p:cNvPicPr>
+          <p:nvPr/>
+        </p:nvPicPr>
+        <p:blipFill>
+          <a:blip r:embed="rId3"/>
+          <a:stretch>
+            <a:fillRect/>
+          </a:stretch>
+        </p:blipFill>
+        <p:spPr>
+          <a:xfrm>
+            <a:off x="11640312" y="64008"/>
+            <a:ext cx="384048" cy="384048"/>
+          </a:xfrm>
+          <a:prstGeom prst="rect">
+            <a:avLst/>
+          </a:prstGeom>
+        </p:spPr>
+      </p:pic>
+      <p:sp>
+        <p:nvSpPr>
+          <p:cNvPr id="25" name="TextBox 24"/>
+          <p:cNvSpPr txBox="1"/>
+          <p:nvPr/>
+        </p:nvSpPr>
+        <p:spPr>
+          <a:xfrm>
+            <a:off x="10314432" y="100584"/>
+            <a:ext cx="1234440" cy="274320"/>
+          </a:xfrm>
+          <a:prstGeom prst="rect">
+            <a:avLst/>
+          </a:prstGeom>
+          <a:noFill/>
+          <a:solidFill>
+            <a:srgbClr val="1A1500">
+              <a:alpha val="90000"/>
+            </a:srgbClr>
+          </a:solidFill>
+          <a:ln w="9525">
+            <a:solidFill>
+              <a:srgbClr val="FFD000"/>
+            </a:solidFill>
+          </a:ln>
+          <a:prstGeom prst="roundRect"/>
+        </p:spPr>
+        <p:txBody>
+          <a:bodyPr wrap="none">
+            <a:spAutoFit/>
+          </a:bodyPr>
+          <a:lstStyle/>
+          <a:p>
+            <a:pPr algn="ctr"/>
+            <a:r>
+              <a:rPr b="1" sz="900">
+                <a:solidFill>
+                  <a:srgbClr val="FFD000"/>
+                </a:solidFill>
+              </a:rPr>
+              <a:t>Team MetaBot</a:t>
+            </a:r>
+          </a:p>
+        </p:txBody>
+      </p:sp>
     </p:spTree>
   </p:cSld>
   <p:clrMapOvr>
@@ -6028,6 +6235,75 @@
           </a:p>
         </p:txBody>
       </p:sp>
+      <p:pic>
+        <p:nvPicPr>
+          <p:cNvPr id="30" name="Picture 29" descr="fk-icon-CTp-Fhev.png"/>
+          <p:cNvPicPr>
+            <a:picLocks noChangeAspect="1"/>
+          </p:cNvPicPr>
+          <p:nvPr/>
+        </p:nvPicPr>
+        <p:blipFill>
+          <a:blip r:embed="rId3"/>
+          <a:stretch>
+            <a:fillRect/>
+          </a:stretch>
+        </p:blipFill>
+        <p:spPr>
+          <a:xfrm>
+            <a:off x="11640312" y="64008"/>
+            <a:ext cx="384048" cy="384048"/>
+          </a:xfrm>
+          <a:prstGeom prst="rect">
+            <a:avLst/>
+          </a:prstGeom>
+        </p:spPr>
+      </p:pic>
+      <p:sp>
+        <p:nvSpPr>
+          <p:cNvPr id="31" name="TextBox 30"/>
+          <p:cNvSpPr txBox="1"/>
+          <p:nvPr/>
+        </p:nvSpPr>
+        <p:spPr>
+          <a:xfrm>
+            <a:off x="10314432" y="100584"/>
+            <a:ext cx="1234440" cy="274320"/>
+          </a:xfrm>
+          <a:prstGeom prst="rect">
+            <a:avLst/>
+          </a:prstGeom>
+          <a:noFill/>
+          <a:solidFill>
+            <a:srgbClr val="1A1500">
+              <a:alpha val="90000"/>
+            </a:srgbClr>
+          </a:solidFill>
+          <a:ln w="9525">
+            <a:solidFill>
+              <a:srgbClr val="FFD000"/>
+            </a:solidFill>
+          </a:ln>
+          <a:prstGeom prst="roundRect"/>
+        </p:spPr>
+        <p:txBody>
+          <a:bodyPr wrap="none">
+            <a:spAutoFit/>
+          </a:bodyPr>
+          <a:lstStyle/>
+          <a:p>
+            <a:pPr algn="ctr"/>
+            <a:r>
+              <a:rPr b="1" sz="900">
+                <a:solidFill>
+                  <a:srgbClr val="FFD000"/>
+                </a:solidFill>
+              </a:rPr>
+              <a:t>Team MetaBot</a:t>
+            </a:r>
+          </a:p>
+        </p:txBody>
+      </p:sp>
     </p:spTree>
   </p:cSld>
   <p:clrMapOvr>
@@ -7044,6 +7320,75 @@
           </a:p>
         </p:txBody>
       </p:sp>
+      <p:pic>
+        <p:nvPicPr>
+          <p:cNvPr id="29" name="Picture 28" descr="fk-icon-CTp-Fhev.png"/>
+          <p:cNvPicPr>
+            <a:picLocks noChangeAspect="1"/>
+          </p:cNvPicPr>
+          <p:nvPr/>
+        </p:nvPicPr>
+        <p:blipFill>
+          <a:blip r:embed="rId3"/>
+          <a:stretch>
+            <a:fillRect/>
+          </a:stretch>
+        </p:blipFill>
+        <p:spPr>
+          <a:xfrm>
+            <a:off x="11640312" y="64008"/>
+            <a:ext cx="384048" cy="384048"/>
+          </a:xfrm>
+          <a:prstGeom prst="rect">
+            <a:avLst/>
+          </a:prstGeom>
+        </p:spPr>
+      </p:pic>
+      <p:sp>
+        <p:nvSpPr>
+          <p:cNvPr id="30" name="TextBox 29"/>
+          <p:cNvSpPr txBox="1"/>
+          <p:nvPr/>
+        </p:nvSpPr>
+        <p:spPr>
+          <a:xfrm>
+            <a:off x="10314432" y="100584"/>
+            <a:ext cx="1234440" cy="274320"/>
+          </a:xfrm>
+          <a:prstGeom prst="rect">
+            <a:avLst/>
+          </a:prstGeom>
+          <a:noFill/>
+          <a:solidFill>
+            <a:srgbClr val="1A1500">
+              <a:alpha val="90000"/>
+            </a:srgbClr>
+          </a:solidFill>
+          <a:ln w="9525">
+            <a:solidFill>
+              <a:srgbClr val="FFD000"/>
+            </a:solidFill>
+          </a:ln>
+          <a:prstGeom prst="roundRect"/>
+        </p:spPr>
+        <p:txBody>
+          <a:bodyPr wrap="none">
+            <a:spAutoFit/>
+          </a:bodyPr>
+          <a:lstStyle/>
+          <a:p>
+            <a:pPr algn="ctr"/>
+            <a:r>
+              <a:rPr b="1" sz="900">
+                <a:solidFill>
+                  <a:srgbClr val="FFD000"/>
+                </a:solidFill>
+              </a:rPr>
+              <a:t>Team MetaBot</a:t>
+            </a:r>
+          </a:p>
+        </p:txBody>
+      </p:sp>
     </p:spTree>
   </p:cSld>
   <p:clrMapOvr>
@@ -8010,6 +8355,75 @@
           </a:p>
         </p:txBody>
       </p:sp>
+      <p:pic>
+        <p:nvPicPr>
+          <p:cNvPr id="27" name="Picture 26" descr="fk-icon-CTp-Fhev.png"/>
+          <p:cNvPicPr>
+            <a:picLocks noChangeAspect="1"/>
+          </p:cNvPicPr>
+          <p:nvPr/>
+        </p:nvPicPr>
+        <p:blipFill>
+          <a:blip r:embed="rId3"/>
+          <a:stretch>
+            <a:fillRect/>
+          </a:stretch>
+        </p:blipFill>
+        <p:spPr>
+          <a:xfrm>
+            <a:off x="11640312" y="64008"/>
+            <a:ext cx="384048" cy="384048"/>
+          </a:xfrm>
+          <a:prstGeom prst="rect">
+            <a:avLst/>
+          </a:prstGeom>
+        </p:spPr>
+      </p:pic>
+      <p:sp>
+        <p:nvSpPr>
+          <p:cNvPr id="28" name="TextBox 27"/>
+          <p:cNvSpPr txBox="1"/>
+          <p:nvPr/>
+        </p:nvSpPr>
+        <p:spPr>
+          <a:xfrm>
+            <a:off x="10314432" y="100584"/>
+            <a:ext cx="1234440" cy="274320"/>
+          </a:xfrm>
+          <a:prstGeom prst="rect">
+            <a:avLst/>
+          </a:prstGeom>
+          <a:noFill/>
+          <a:solidFill>
+            <a:srgbClr val="1A1500">
+              <a:alpha val="90000"/>
+            </a:srgbClr>
+          </a:solidFill>
+          <a:ln w="9525">
+            <a:solidFill>
+              <a:srgbClr val="FFD000"/>
+            </a:solidFill>
+          </a:ln>
+          <a:prstGeom prst="roundRect"/>
+        </p:spPr>
+        <p:txBody>
+          <a:bodyPr wrap="none">
+            <a:spAutoFit/>
+          </a:bodyPr>
+          <a:lstStyle/>
+          <a:p>
+            <a:pPr algn="ctr"/>
+            <a:r>
+              <a:rPr b="1" sz="900">
+                <a:solidFill>
+                  <a:srgbClr val="FFD000"/>
+                </a:solidFill>
+              </a:rPr>
+              <a:t>Team MetaBot</a:t>
+            </a:r>
+          </a:p>
+        </p:txBody>
+      </p:sp>
     </p:spTree>
   </p:cSld>
   <p:clrMapOvr>
@@ -9130,6 +9544,75 @@
           </a:p>
         </p:txBody>
       </p:sp>
+      <p:pic>
+        <p:nvPicPr>
+          <p:cNvPr id="31" name="Picture 30" descr="fk-icon-CTp-Fhev.png"/>
+          <p:cNvPicPr>
+            <a:picLocks noChangeAspect="1"/>
+          </p:cNvPicPr>
+          <p:nvPr/>
+        </p:nvPicPr>
+        <p:blipFill>
+          <a:blip r:embed="rId3"/>
+          <a:stretch>
+            <a:fillRect/>
+          </a:stretch>
+        </p:blipFill>
+        <p:spPr>
+          <a:xfrm>
+            <a:off x="11640312" y="64008"/>
+            <a:ext cx="384048" cy="384048"/>
+          </a:xfrm>
+          <a:prstGeom prst="rect">
+            <a:avLst/>
+          </a:prstGeom>
+        </p:spPr>
+      </p:pic>
+      <p:sp>
+        <p:nvSpPr>
+          <p:cNvPr id="32" name="TextBox 31"/>
+          <p:cNvSpPr txBox="1"/>
+          <p:nvPr/>
+        </p:nvSpPr>
+        <p:spPr>
+          <a:xfrm>
+            <a:off x="10314432" y="100584"/>
+            <a:ext cx="1234440" cy="274320"/>
+          </a:xfrm>
+          <a:prstGeom prst="rect">
+            <a:avLst/>
+          </a:prstGeom>
+          <a:noFill/>
+          <a:solidFill>
+            <a:srgbClr val="1A1500">
+              <a:alpha val="90000"/>
+            </a:srgbClr>
+          </a:solidFill>
+          <a:ln w="9525">
+            <a:solidFill>
+              <a:srgbClr val="FFD000"/>
+            </a:solidFill>
+          </a:ln>
+          <a:prstGeom prst="roundRect"/>
+        </p:spPr>
+        <p:txBody>
+          <a:bodyPr wrap="none">
+            <a:spAutoFit/>
+          </a:bodyPr>
+          <a:lstStyle/>
+          <a:p>
+            <a:pPr algn="ctr"/>
+            <a:r>
+              <a:rPr b="1" sz="900">
+                <a:solidFill>
+                  <a:srgbClr val="FFD000"/>
+                </a:solidFill>
+              </a:rPr>
+              <a:t>Team MetaBot</a:t>
+            </a:r>
+          </a:p>
+        </p:txBody>
+      </p:sp>
     </p:spTree>
   </p:cSld>
   <p:clrMapOvr>
@@ -9766,6 +10249,75 @@
                 </a:solidFill>
               </a:rPr>
               <a:t>→  Expand to PS2/PS3: incident detection + signal optimization</a:t>
+            </a:r>
+          </a:p>
+        </p:txBody>
+      </p:sp>
+      <p:pic>
+        <p:nvPicPr>
+          <p:cNvPr id="19" name="Picture 18" descr="fk-icon-CTp-Fhev.png"/>
+          <p:cNvPicPr>
+            <a:picLocks noChangeAspect="1"/>
+          </p:cNvPicPr>
+          <p:nvPr/>
+        </p:nvPicPr>
+        <p:blipFill>
+          <a:blip r:embed="rId3"/>
+          <a:stretch>
+            <a:fillRect/>
+          </a:stretch>
+        </p:blipFill>
+        <p:spPr>
+          <a:xfrm>
+            <a:off x="11640312" y="64008"/>
+            <a:ext cx="384048" cy="384048"/>
+          </a:xfrm>
+          <a:prstGeom prst="rect">
+            <a:avLst/>
+          </a:prstGeom>
+        </p:spPr>
+      </p:pic>
+      <p:sp>
+        <p:nvSpPr>
+          <p:cNvPr id="20" name="TextBox 19"/>
+          <p:cNvSpPr txBox="1"/>
+          <p:nvPr/>
+        </p:nvSpPr>
+        <p:spPr>
+          <a:xfrm>
+            <a:off x="10314432" y="100584"/>
+            <a:ext cx="1234440" cy="274320"/>
+          </a:xfrm>
+          <a:prstGeom prst="rect">
+            <a:avLst/>
+          </a:prstGeom>
+          <a:noFill/>
+          <a:solidFill>
+            <a:srgbClr val="1A1500">
+              <a:alpha val="90000"/>
+            </a:srgbClr>
+          </a:solidFill>
+          <a:ln w="9525">
+            <a:solidFill>
+              <a:srgbClr val="FFD000"/>
+            </a:solidFill>
+          </a:ln>
+          <a:prstGeom prst="roundRect"/>
+        </p:spPr>
+        <p:txBody>
+          <a:bodyPr wrap="none">
+            <a:spAutoFit/>
+          </a:bodyPr>
+          <a:lstStyle/>
+          <a:p>
+            <a:pPr algn="ctr"/>
+            <a:r>
+              <a:rPr b="1" sz="900">
+                <a:solidFill>
+                  <a:srgbClr val="FFD000"/>
+                </a:solidFill>
+              </a:rPr>
+              <a:t>Team MetaBot</a:t>
             </a:r>
           </a:p>
         </p:txBody>

</xml_diff>

<commit_message>
fix: update presentation — correct all numbers, add 91%/r=0.79/metro findings
Slide 3: 6-tab → 8-tab; Smart Patrol Advisor + Corridor Risk replace old feature boxes
Slide 5: Safina Plaza 15000+ → 5882; r=-0.14 → r=+0.79; '54 stations' → '91% spatial'
Slide 6: Formula 0.40/0.30/0.20/0.10 → 0.60/0.25/0.15; 4th box = output (25 HIGH/58 MED/84 LOW)
Slide 7: Enforcement Optimizer → Smart Enforcement Plan; Sunday 9AM example added
Slide 8: 2000+/week → 65/day; 91%+r=0.79+metro+₹17Cr in impact bullets
</commit_message>
<xml_diff>
--- a/assets/ParkIQ_Presentation.pptx
+++ b/assets/ParkIQ_Presentation.pptx
@@ -4475,7 +4475,7 @@
                   <a:srgbClr val="AAAAAA"/>
                 </a:solidFill>
               </a:rPr>
-              <a:t>6-tab Streamlit intelligence platform — from raw violation data to deployable patrol schedules</a:t>
+              <a:t>8-tab Streamlit intelligence platform — from raw violation data to deployable patrol schedules</a:t>
             </a:r>
           </a:p>
         </p:txBody>
@@ -5000,7 +5000,7 @@
                   <a:srgbClr val="E94560"/>
                 </a:solidFill>
               </a:rPr>
-              <a:t>🚓  Enforcement Optimizer</a:t>
+              <a:t>🎯  Smart Patrol Advisor</a:t>
             </a:r>
           </a:p>
         </p:txBody>
@@ -5034,8 +5034,8 @@
                   <a:srgbClr val="FFFFFF"/>
                 </a:solidFill>
               </a:rPr>
-              <a:t>Shift-wise patrol schedule
-for N available officers</a:t>
+              <a:t>Time-aware: select hour+day
+→ top junctions to deploy NOW</a:t>
             </a:r>
           </a:p>
         </p:txBody>
@@ -5112,7 +5112,7 @@
                   <a:srgbClr val="E94560"/>
                 </a:solidFill>
               </a:rPr>
-              <a:t>🚗  Vehicle Intelligence</a:t>
+              <a:t>🛣️  Corridor Risk + AI</a:t>
             </a:r>
           </a:p>
         </p:txBody>
@@ -5146,8 +5146,8 @@
                   <a:srgbClr val="FFFFFF"/>
                 </a:solidFill>
               </a:rPr>
-              <a:t>Vehicle type breakdown
-Cross-hour heatmap</a:t>
+              <a:t>21 ASTRAM corridors ranked
+Random Forest AUC 0.89</a:t>
             </a:r>
           </a:p>
         </p:txBody>
@@ -6590,7 +6590,7 @@
                   <a:srgbClr val="FFFFFF"/>
                 </a:solidFill>
               </a:rPr>
-              <a:t>15,000+ violations; top priority zone for enforcement</a:t>
+              <a:t>5,882 violations (approved); #1 priority enforcement zone</a:t>
             </a:r>
           </a:p>
         </p:txBody>
@@ -7136,7 +7136,7 @@
                   <a:srgbClr val="E94560"/>
                 </a:solidFill>
               </a:rPr>
-              <a:t>r = −0.14 (ASTRAM data)</a:t>
+              <a:t>r = +0.79 (temporal)</a:t>
             </a:r>
           </a:p>
         </p:txBody>
@@ -7170,7 +7170,7 @@
                   <a:srgbClr val="FFFFFF"/>
                 </a:solidFill>
               </a:rPr>
-              <a:t>Stations with active enforcement see fewer traffic incidents</a:t>
+              <a:t>Violations &amp; incidents peak at same hours — strong hourly correlation</a:t>
             </a:r>
           </a:p>
         </p:txBody>
@@ -7247,7 +7247,7 @@
                   <a:srgbClr val="AAAAAA"/>
                 </a:solidFill>
               </a:rPr>
-              <a:t>Scale</a:t>
+              <a:t>Spatial Impact</a:t>
             </a:r>
           </a:p>
         </p:txBody>
@@ -7281,7 +7281,7 @@
                   <a:srgbClr val="E94560"/>
                 </a:solidFill>
               </a:rPr>
-              <a:t>54 stations covered</a:t>
+              <a:t>91% of incidents</a:t>
             </a:r>
           </a:p>
         </p:txBody>
@@ -7315,7 +7315,7 @@
                   <a:srgbClr val="FFFFFF"/>
                 </a:solidFill>
               </a:rPr>
-              <a:t>Complete spatial coverage — no enforcement gaps in analysis</a:t>
+              <a:t>of ASTRAM traffic incidents occur within 500 m of a parking violation cluster</a:t>
             </a:r>
           </a:p>
         </p:txBody>
@@ -7564,7 +7564,7 @@
                   <a:srgbClr val="AAAAAA"/>
                 </a:solidFill>
               </a:rPr>
-              <a:t>Each junction scored 0–1 using a 4-factor composite model:</a:t>
+              <a:t>Each junction scored 0–1 using a 3-factor composite model (normalized 0→1):</a:t>
             </a:r>
           </a:p>
         </p:txBody>
@@ -7641,7 +7641,7 @@
                   <a:srgbClr val="0F0F23"/>
                 </a:solidFill>
               </a:rPr>
-              <a:t>40%</a:t>
+              <a:t>60%</a:t>
             </a:r>
           </a:p>
         </p:txBody>
@@ -7829,7 +7829,7 @@
                   <a:srgbClr val="0F0F23"/>
                 </a:solidFill>
               </a:rPr>
-              <a:t>30%</a:t>
+              <a:t>25%</a:t>
             </a:r>
           </a:p>
         </p:txBody>
@@ -7940,7 +7940,7 @@
                   <a:srgbClr val="AAAAAA"/>
                 </a:solidFill>
               </a:rPr>
-              <a:t>Violations during 8–11 AM / total — targets rush-hour congestion windows</a:t>
+              <a:t>Violations during 8–11 AM / total — targets morning rush enforcement window</a:t>
             </a:r>
           </a:p>
         </p:txBody>
@@ -8017,7 +8017,7 @@
                   <a:srgbClr val="0F0F23"/>
                 </a:solidFill>
               </a:rPr>
-              <a:t>20%</a:t>
+              <a:t>15%</a:t>
             </a:r>
           </a:p>
         </p:txBody>
@@ -8094,7 +8094,7 @@
                   <a:srgbClr val="FFFFFF"/>
                 </a:solidFill>
               </a:rPr>
-              <a:t>Incident Correlation</a:t>
+              <a:t>Vehicle Severity Score</a:t>
             </a:r>
           </a:p>
         </p:txBody>
@@ -8128,7 +8128,7 @@
                   <a:srgbClr val="AAAAAA"/>
                 </a:solidFill>
               </a:rPr>
-              <a:t>ASTRAM incident rate at same police station — links parking to real congestion</a:t>
+              <a:t>Avg severity weight (Truck=3× vs Scooter=0.5) — prioritises blockage impact</a:t>
             </a:r>
           </a:p>
         </p:txBody>
@@ -8205,7 +8205,7 @@
                   <a:srgbClr val="0F0F23"/>
                 </a:solidFill>
               </a:rPr>
-              <a:t>10%</a:t>
+              <a:t>→</a:t>
             </a:r>
           </a:p>
         </p:txBody>
@@ -8282,7 +8282,7 @@
                   <a:srgbClr val="FFFFFF"/>
                 </a:solidFill>
               </a:rPr>
-              <a:t>Vehicle Severity Score</a:t>
+              <a:t>Output</a:t>
             </a:r>
           </a:p>
         </p:txBody>
@@ -8316,7 +8316,8 @@
                   <a:srgbClr val="AAAAAA"/>
                 </a:solidFill>
               </a:rPr>
-              <a:t>Avg severity weight (Truck=3× vs Scooter=0.5) — prioritizes high-impact blockages</a:t>
+              <a:t>25 HIGH · 58 MEDIUM · 84 LOW — across 167 BTP junctions
+35 flagged near BMRC metro stations 🚇</a:t>
             </a:r>
           </a:p>
         </p:txBody>
@@ -8350,7 +8351,7 @@
                   <a:srgbClr val="F5A623"/>
                 </a:solidFill>
               </a:rPr>
-              <a:t>Score = 0.40 × Freq + 0.30 × Peak + 0.20 × Incident + 0.10 × Severity</a:t>
+              <a:t>Score = 0.60 × Freq + 0.25 × Peak + 0.15 × Severity  →  normalized to 0–1</a:t>
             </a:r>
           </a:p>
         </p:txBody>
@@ -8565,7 +8566,7 @@
                   <a:srgbClr val="FFFFFF"/>
                 </a:solidFill>
               </a:rPr>
-              <a:t>Enforcement Optimizer</a:t>
+              <a:t>Smart Enforcement Plan</a:t>
             </a:r>
           </a:p>
         </p:txBody>
@@ -8599,7 +8600,7 @@
                   <a:srgbClr val="F5A623"/>
                 </a:solidFill>
               </a:rPr>
-              <a:t>Officers  →  Zones  →  Shifts  →  Map</a:t>
+              <a:t>Officers  →  Patrol Advisor  →  Zones  →  Shifts  →  Deploy</a:t>
             </a:r>
           </a:p>
         </p:txBody>
@@ -9163,7 +9164,7 @@
                   <a:srgbClr val="FFFFFF"/>
                 </a:solidFill>
               </a:rPr>
-              <a:t>Officers assigned to top N zones across 3 shifts (Morning / Late Morning / Night)</a:t>
+              <a:t>Smart Patrol Advisor: select day + hour → top 5 junctions with historical violation counts at that exact time window</a:t>
             </a:r>
           </a:p>
         </p:txBody>
@@ -9539,7 +9540,7 @@
                   <a:srgbClr val="FFFFFF"/>
                 </a:solidFill>
               </a:rPr>
-              <a:t>Projected violations addressable per deployment cycle displayed</a:t>
+              <a:t>Sunday 09:00 → Safina Plaza (271 violations), Elite (131) — real data, real decisions</a:t>
             </a:r>
           </a:p>
         </p:txBody>
@@ -9865,7 +9866,7 @@
                   <a:srgbClr val="FFFFFF"/>
                 </a:solidFill>
               </a:rPr>
-              <a:t>✓  115,400 approved violations geo-mapped across 54 stations</a:t>
+              <a:t>✓  115,400 approved violations + 8,173 ASTRAM incidents cross-analysed</a:t>
             </a:r>
           </a:p>
         </p:txBody>
@@ -9899,7 +9900,7 @@
                   <a:srgbClr val="FFFFFF"/>
                 </a:solidFill>
               </a:rPr>
-              <a:t>✓  Top 5 junctions → 40% of all hotspot violations addressed</a:t>
+              <a:t>✓  91% spatial co-location + r=0.79 temporal proof: parking drives congestion</a:t>
             </a:r>
           </a:p>
         </p:txBody>
@@ -9933,7 +9934,7 @@
                   <a:srgbClr val="FFFFFF"/>
                 </a:solidFill>
               </a:rPr>
-              <a:t>✓  Peak window identified: 10 AM enforement maximises reduction</a:t>
+              <a:t>✓  35 metro-adjacent junctions flagged — spillover parking quantified</a:t>
             </a:r>
           </a:p>
         </p:txBody>
@@ -9967,7 +9968,7 @@
                   <a:srgbClr val="FFFFFF"/>
                 </a:solidFill>
               </a:rPr>
-              <a:t>✓  Enforcement deployment can save est. 2,000+ vehicle-hours/week</a:t>
+              <a:t>✓  65 vehicle-hours lost per day (9,200 total) — quantified traffic flow impact</a:t>
             </a:r>
           </a:p>
         </p:txBody>
@@ -10001,7 +10002,7 @@
                   <a:srgbClr val="FFFFFF"/>
                 </a:solidFill>
               </a:rPr>
-              <a:t>✓  Scalable to real-time feed when integrated with BTP systems</a:t>
+              <a:t>✓  ₹17 Cr/month economic cost — cost-benefit case for enforcement investment</a:t>
             </a:r>
           </a:p>
         </p:txBody>

</xml_diff>